<commit_message>
Put the Peres logo on all four deliverables
The department template ships the logo of a different institution, the
Academic Center for Law and Business in Ramat Gan, on every slide. It is
replaced with the Peres Academic Center mark, and the picture box is
changed from the template's landscape rectangle to a square so the mark
keeps its aspect ratio.

The two Word documents gain the logo on their cover pages, which the
course handbook lists among the required cover elements and which they
were missing.

Also corrects the methodological note in the interview appendix, which
still gave interview length as one to one and a half hours after the
interviews themselves were brought into the required thirty to forty
five minute window.

Co-Authored-By: Claude Fable 5 <noreply@anthropic.com>
Claude-Session: https://claude.ai/code/session_01Aebwgiv2BDsZYZ7oiMCAJ9
</commit_message>
<xml_diff>
--- a/seminar-interviews/מצגת-פרויקט-גמר-ממוגרפיה.pptx
+++ b/seminar-interviews/מצגת-פרויקט-גמר-ממוגרפיה.pptx
@@ -2390,7 +2390,7 @@
       </p:grpSpPr>
       <p:pic>
         <p:nvPicPr>
-          <p:cNvPr id="2" name="Image 0" descr="/root/.claude/uploads/2ca03497-42eb-5d34-8079-069f09f39de3/e4536213-image.jpg">    </p:cNvPr>
+          <p:cNvPr id="2" name="Image 0" descr="/tmp/claude-0/-home-user-clickwriting-landing/2ca03497-42eb-5d34-8079-069f09f39de3/scratchpad/work/peres_logo.jpg">    </p:cNvPr>
           <p:cNvPicPr>
             <a:picLocks noChangeAspect="1"/>
           </p:cNvPicPr>
@@ -9300,7 +9300,7 @@
       </p:sp>
       <p:pic>
         <p:nvPicPr>
-          <p:cNvPr id="3" name="Image 0" descr="/root/.claude/uploads/2ca03497-42eb-5d34-8079-069f09f39de3/e4536213-image.jpg">    </p:cNvPr>
+          <p:cNvPr id="3" name="Image 0" descr="/tmp/claude-0/-home-user-clickwriting-landing/2ca03497-42eb-5d34-8079-069f09f39de3/scratchpad/work/peres_logo.jpg">    </p:cNvPr>
           <p:cNvPicPr>
             <a:picLocks noChangeAspect="1"/>
           </p:cNvPicPr>

</xml_diff>